<commit_message>
Add submission notebook polish, demo script, and supporting assets
- Add AI574_Submission_Clean.ipynb with architecture framing, baseline clarity,
  learned router/grader evaluation wording, and grader-facing comparisons
- Add build_submission_notebook.py helper
- Update slide notes, Multi Domain Agent and Finetune notebooks, presentation
- Add AI574_Demo_Script.md

Made-with: Cursor
</commit_message>
<xml_diff>
--- a/presentation_fixed.pptx
+++ b/presentation_fixed.pptx
@@ -2232,92 +2232,110 @@
               </a:defRPr>
             </a:pPr>
             <a:r>
-              <a:rPr sz="1500" b="1"/>
+              <a:rPr sz="1300" b="1"/>
               <a:t>LLM (primary):</a:t>
             </a:r>
             <a:r>
-              <a:rPr sz="1500" b="0"/>
+              <a:rPr sz="1300" b="0"/>
               <a:t> Gemini 2.5 Flash — supervisor routing, document grading, query rewriting, synthesis, fallback, response generation</a:t>
             </a:r>
           </a:p>
           <a:p>
             <a:pPr/>
             <a:r>
-              <a:rPr sz="1500" b="1"/>
+              <a:rPr sz="1300" b="1"/>
               <a:t>LLM (local failover):</a:t>
             </a:r>
             <a:r>
-              <a:rPr sz="1500" b="0"/>
+              <a:rPr sz="1300" b="0"/>
               <a:t> Gemma 3 12B — keeps the system operational when the API is unreachable</a:t>
             </a:r>
           </a:p>
           <a:p>
             <a:pPr/>
             <a:r>
-              <a:rPr sz="1500" b="1"/>
+              <a:rPr sz="1300" b="1"/>
+              <a:t>Routing — two-tier text classification:</a:t>
+            </a:r>
+          </a:p>
+          <a:p>
+            <a:pPr lvl="1"/>
+            <a:r>
+              <a:rPr sz="1300" b="1"/>
+              <a:t>Tier 1:</a:t>
+            </a:r>
+            <a:r>
+              <a:rPr sz="1300" b="0"/>
+              <a:t> lightweight lexical / keyword text classifier (rule-based, no LLM call) — handles obvious queries cheaply</a:t>
+            </a:r>
+          </a:p>
+          <a:p>
+            <a:pPr lvl="1"/>
+            <a:r>
+              <a:rPr sz="1300" b="1"/>
+              <a:t>Tier 2:</a:t>
+            </a:r>
+            <a:r>
+              <a:rPr sz="1300" b="0"/>
+              <a:t> LLM-based zero-shot supervisor — handles ambiguous queries; emits domain + confidence + second-choice</a:t>
+            </a:r>
+          </a:p>
+          <a:p>
+            <a:pPr/>
+            <a:r>
+              <a:rPr sz="1300" b="1"/>
               <a:t>Embedding model:</a:t>
             </a:r>
             <a:r>
-              <a:rPr sz="1500" b="0"/>
-              <a:t> GTE-Large (1024-dimensional vectors)</a:t>
+              <a:rPr sz="1300" b="0"/>
+              <a:t> GTE-Large (1024-dim vectors)</a:t>
             </a:r>
           </a:p>
           <a:p>
             <a:pPr/>
             <a:r>
-              <a:rPr sz="1500" b="1"/>
+              <a:rPr sz="1300" b="1"/>
               <a:t>Vector database:</a:t>
             </a:r>
             <a:r>
-              <a:rPr sz="1500" b="0"/>
+              <a:rPr sz="1300" b="0"/>
               <a:t> ChromaDB with separate collections per domain</a:t>
             </a:r>
           </a:p>
           <a:p>
             <a:pPr/>
             <a:r>
-              <a:rPr sz="1500" b="1"/>
-              <a:t>Normalization:</a:t>
-            </a:r>
-            <a:r>
-              <a:rPr sz="1500" b="0"/>
-              <a:t> clean text, normalize technical terms / recipe fields / paper metadata, standardize embeddings</a:t>
+              <a:rPr sz="1300" b="1"/>
+              <a:t>No model fine-tuning</a:t>
+            </a:r>
+            <a:r>
+              <a:rPr sz="1300" b="0"/>
+              <a:t> — reliability comes from retrieval grading, domain prompts, and source grounding</a:t>
             </a:r>
           </a:p>
           <a:p>
             <a:pPr/>
             <a:r>
-              <a:rPr sz="1500" b="1"/>
-              <a:t>Regularization:</a:t>
-            </a:r>
-            <a:r>
-              <a:rPr sz="1500" b="0"/>
-              <a:t> no model fine-tuning — reliability comes from retrieval grading, domain prompts, and source grounding</a:t>
+              <a:rPr sz="1300" b="1"/>
+              <a:t>Data augmentation:</a:t>
+            </a:r>
+            <a:r>
+              <a:rPr sz="1300" b="0"/>
+              <a:t> CRAG query rewriting + domain-specific terminology expansion</a:t>
             </a:r>
           </a:p>
           <a:p>
             <a:pPr/>
             <a:r>
-              <a:rPr sz="1500" b="1"/>
-              <a:t>Data augmentation:</a:t>
-            </a:r>
-            <a:r>
-              <a:rPr sz="1500" b="0"/>
-              <a:t> CRAG query rewriting + domain-specific terminology expansion</a:t>
-            </a:r>
-          </a:p>
-          <a:p>
-            <a:pPr/>
-            <a:r>
-              <a:rPr sz="1500" b="1"/>
+              <a:rPr sz="1300" b="1"/>
               <a:t>Tuning parameters:</a:t>
             </a:r>
           </a:p>
           <a:p>
             <a:pPr lvl="1"/>
             <a:r>
-              <a:rPr sz="1500" b="0"/>
-              <a:t>Routing confidence threshold · Top-k retrieval · Max 2 rewrite attempts · Per-agent prompt tuning</a:t>
+              <a:rPr sz="1300" b="0"/>
+              <a:t>Routing confidence threshold · Lexical-router threshold · Top-k retrieval · Max 2 rewrite attempts · Per-agent prompt tuning</a:t>
             </a:r>
           </a:p>
         </p:txBody>
@@ -2961,78 +2979,93 @@
               </a:defRPr>
             </a:pPr>
             <a:r>
-              <a:rPr sz="1600" b="1"/>
+              <a:rPr sz="1400" b="1"/>
               <a:t>Hypothesis:</a:t>
             </a:r>
             <a:r>
-              <a:rPr sz="1600" b="0"/>
+              <a:rPr sz="1400" b="0"/>
               <a:t> the multi-agent system outperforms the monolithic RAG baseline on all four metrics</a:t>
             </a:r>
           </a:p>
           <a:p>
             <a:pPr/>
             <a:r>
-              <a:rPr sz="1600" b="1"/>
+              <a:rPr sz="1400" b="1"/>
               <a:t>Higher routing accuracy</a:t>
             </a:r>
             <a:r>
-              <a:rPr sz="1600" b="0"/>
+              <a:rPr sz="1400" b="0"/>
               <a:t> — supervisor sends queries to the correct domain agent (or correctly clarifies)</a:t>
             </a:r>
           </a:p>
           <a:p>
             <a:pPr/>
             <a:r>
-              <a:rPr sz="1600" b="1"/>
+              <a:rPr sz="1400" b="1"/>
               <a:t>Better retrieval precision</a:t>
             </a:r>
             <a:r>
-              <a:rPr sz="1600" b="0"/>
+              <a:rPr sz="1400" b="0"/>
               <a:t> — each domain has its own isolated knowledge base</a:t>
             </a:r>
           </a:p>
           <a:p>
             <a:pPr/>
             <a:r>
-              <a:rPr sz="1600" b="1"/>
+              <a:rPr sz="1400" b="1"/>
               <a:t>Lower hallucination rate</a:t>
             </a:r>
             <a:r>
-              <a:rPr sz="1600" b="0"/>
+              <a:rPr sz="1400" b="0"/>
               <a:t> — CRAG grades retrieved documents before generating answers</a:t>
             </a:r>
           </a:p>
           <a:p>
             <a:pPr/>
             <a:r>
-              <a:rPr sz="1600" b="1"/>
+              <a:rPr sz="1400" b="1"/>
               <a:t>Higher task completion</a:t>
             </a:r>
             <a:r>
-              <a:rPr sz="1600" b="0"/>
+              <a:rPr sz="1400" b="0"/>
               <a:t> — weak retrievals get rewritten and retried; synthesis handles cross-domain queries; fallback handles out-of-scope queries safely</a:t>
             </a:r>
           </a:p>
           <a:p>
             <a:pPr/>
             <a:r>
-              <a:rPr sz="1600" b="1"/>
+              <a:rPr sz="1400" b="1"/>
               <a:t>Main expected finding:</a:t>
             </a:r>
           </a:p>
           <a:p>
             <a:pPr lvl="1"/>
             <a:r>
-              <a:rPr sz="1600" b="0"/>
+              <a:rPr sz="1400" b="0"/>
               <a:t>Domain specialization + corrective retrieval = more reliable NLP responses across heterogeneous query types — </a:t>
             </a:r>
             <a:r>
-              <a:rPr sz="1600" b="1"/>
+              <a:rPr sz="1400" b="1"/>
               <a:t>architecture matters as much as model choice</a:t>
             </a:r>
-            <a:r>
-              <a:rPr sz="1600" b="0"/>
-              <a:t>.</a:t>
+          </a:p>
+          <a:p>
+            <a:pPr/>
+            <a:r>
+              <a:rPr sz="1400" b="1"/>
+              <a:t>Forward-looking:</a:t>
+            </a:r>
+            <a:r>
+              <a:rPr sz="1400" b="0"/>
+              <a:t> the same architecture is designed to extend to a </a:t>
+            </a:r>
+            <a:r>
+              <a:rPr sz="1400" b="1"/>
+              <a:t>multi-turn task-completion agent</a:t>
+            </a:r>
+            <a:r>
+              <a:rPr sz="1400" b="0"/>
+              <a:t> — supervisor routing, tool use, retry, and fallback are the substrate; planning and stateful execution are the natural next layer (see Future Work)</a:t>
             </a:r>
           </a:p>
         </p:txBody>
@@ -3167,197 +3200,101 @@
               </a:defRPr>
             </a:pPr>
             <a:r>
+              <a:rPr sz="1300" b="0"/>
               <a:t>Multi-domain NLP systems need more than a strong language model</a:t>
             </a:r>
           </a:p>
           <a:p>
-            <a:pPr marL="233111" indent="-233111" defTabSz="425195">
-              <a:lnSpc>
-                <a:spcPct val="100000"/>
-              </a:lnSpc>
-              <a:spcBef>
-                <a:spcPts val="0"/>
-              </a:spcBef>
-              <a:buFontTx/>
-              <a:defRPr sz="2325">
-                <a:latin typeface="Times Roman"/>
-                <a:ea typeface="Times Roman"/>
-                <a:cs typeface="Times Roman"/>
-                <a:sym typeface="Times Roman"/>
-              </a:defRPr>
-            </a:pPr>
-            <a:r>
-              <a:rPr b="1"/>
+            <a:pPr/>
+            <a:r>
+              <a:rPr sz="1300" b="1"/>
               <a:t>Architecture matters:</a:t>
             </a:r>
             <a:r>
+              <a:rPr sz="1300" b="0"/>
               <a:t> routing, domain separation, and retrieval correction can improve reliability</a:t>
             </a:r>
           </a:p>
           <a:p>
-            <a:pPr marL="233111" indent="-233111" defTabSz="425195">
-              <a:lnSpc>
-                <a:spcPct val="100000"/>
-              </a:lnSpc>
-              <a:spcBef>
-                <a:spcPts val="0"/>
-              </a:spcBef>
-              <a:buFontTx/>
-              <a:defRPr sz="2325">
-                <a:latin typeface="Times Roman"/>
-                <a:ea typeface="Times Roman"/>
-                <a:cs typeface="Times Roman"/>
-                <a:sym typeface="Times Roman"/>
-              </a:defRPr>
-            </a:pPr>
-            <a:r>
+            <a:pPr/>
+            <a:r>
+              <a:rPr sz="1300" b="0"/>
               <a:t>Domain-specific preprocessing helps the system better understand technical terms, recipe details, and research metadata</a:t>
             </a:r>
           </a:p>
           <a:p>
-            <a:pPr marL="233111" indent="-233111" defTabSz="425195">
-              <a:lnSpc>
-                <a:spcPct val="100000"/>
-              </a:lnSpc>
-              <a:spcBef>
-                <a:spcPts val="0"/>
-              </a:spcBef>
-              <a:buFontTx/>
-              <a:defRPr sz="2325">
-                <a:latin typeface="Times Roman"/>
-                <a:ea typeface="Times Roman"/>
-                <a:cs typeface="Times Roman"/>
-                <a:sym typeface="Times Roman"/>
-              </a:defRPr>
-            </a:pPr>
-            <a:r>
+            <a:pPr/>
+            <a:r>
+              <a:rPr sz="1300" b="0"/>
               <a:t>CRAG adds value by reducing weak retrieval and unsupported responses</a:t>
             </a:r>
           </a:p>
           <a:p>
-            <a:pPr marL="233111" indent="-233111" defTabSz="425195">
-              <a:lnSpc>
-                <a:spcPct val="100000"/>
-              </a:lnSpc>
-              <a:spcBef>
-                <a:spcPts val="0"/>
-              </a:spcBef>
-              <a:buFontTx/>
-              <a:defRPr sz="2325">
-                <a:latin typeface="Times Roman"/>
-                <a:ea typeface="Times Roman"/>
-                <a:cs typeface="Times Roman"/>
-                <a:sym typeface="Times Roman"/>
-              </a:defRPr>
-            </a:pPr>
-            <a:r>
+            <a:pPr/>
+            <a:r>
+              <a:rPr sz="1300" b="1"/>
               <a:t>Main tradeoff:</a:t>
             </a:r>
-            <a:br>
-              <a:rPr/>
-            </a:br>
-            <a:r>
-              <a:t>More correction steps can improve accuracy but may increase response time</a:t>
-            </a:r>
-          </a:p>
-          <a:p>
-            <a:pPr marL="233111" indent="-233111" defTabSz="425195">
-              <a:lnSpc>
-                <a:spcPct val="100000"/>
-              </a:lnSpc>
-              <a:spcBef>
-                <a:spcPts val="0"/>
-              </a:spcBef>
-              <a:buFontTx/>
-              <a:defRPr sz="2325">
-                <a:latin typeface="Times Roman"/>
-                <a:ea typeface="Times Roman"/>
-                <a:cs typeface="Times Roman"/>
-                <a:sym typeface="Times Roman"/>
-              </a:defRPr>
-            </a:pPr>
-            <a:r>
+            <a:r>
+              <a:rPr sz="1300" b="0"/>
+              <a:t> more correction steps can improve accuracy but may increase response time</a:t>
+            </a:r>
+          </a:p>
+          <a:p>
+            <a:pPr/>
+            <a:r>
+              <a:rPr sz="1300" b="1"/>
+              <a:t>The architecture is a reusable substrate for agentic systems</a:t>
+            </a:r>
+            <a:r>
+              <a:rPr sz="1300" b="0"/>
+              <a:t> — not just RAG</a:t>
+            </a:r>
+          </a:p>
+          <a:p>
+            <a:pPr/>
+            <a:r>
+              <a:rPr sz="1300" b="1"/>
               <a:t>Future improvements:</a:t>
             </a:r>
           </a:p>
           <a:p>
-            <a:pPr marL="233111" indent="-233111" defTabSz="425195">
-              <a:lnSpc>
-                <a:spcPct val="100000"/>
-              </a:lnSpc>
-              <a:spcBef>
-                <a:spcPts val="0"/>
-              </a:spcBef>
-              <a:buFontTx/>
-              <a:defRPr sz="2325">
-                <a:latin typeface="Times Roman"/>
-                <a:ea typeface="Times Roman"/>
-                <a:cs typeface="Times Roman"/>
-                <a:sym typeface="Times Roman"/>
-              </a:defRPr>
-            </a:pPr>
-            <a:r>
-              <a:t>Add more domains</a:t>
-            </a:r>
-          </a:p>
-          <a:p>
-            <a:pPr marL="233111" indent="-233111" defTabSz="425195">
-              <a:lnSpc>
-                <a:spcPct val="100000"/>
-              </a:lnSpc>
-              <a:spcBef>
-                <a:spcPts val="0"/>
-              </a:spcBef>
-              <a:buFontTx/>
-              <a:defRPr sz="2325">
-                <a:latin typeface="Times Roman"/>
-                <a:ea typeface="Times Roman"/>
-                <a:cs typeface="Times Roman"/>
-                <a:sym typeface="Times Roman"/>
-              </a:defRPr>
-            </a:pPr>
-            <a:r>
-              <a:t>Optimize latency</a:t>
-            </a:r>
-          </a:p>
-          <a:p>
-            <a:pPr marL="233111" indent="-233111" defTabSz="425195">
-              <a:lnSpc>
-                <a:spcPct val="100000"/>
-              </a:lnSpc>
-              <a:spcBef>
-                <a:spcPts val="0"/>
-              </a:spcBef>
-              <a:buFontTx/>
-              <a:defRPr sz="2325">
-                <a:latin typeface="Times Roman"/>
-                <a:ea typeface="Times Roman"/>
-                <a:cs typeface="Times Roman"/>
-                <a:sym typeface="Times Roman"/>
-              </a:defRPr>
-            </a:pPr>
-            <a:r>
-              <a:t>Improve routing confidence thresholds</a:t>
-            </a:r>
-          </a:p>
-          <a:p>
-            <a:pPr marL="233111" indent="-233111" defTabSz="425195">
-              <a:lnSpc>
-                <a:spcPct val="100000"/>
-              </a:lnSpc>
-              <a:spcBef>
-                <a:spcPts val="0"/>
-              </a:spcBef>
-              <a:buFontTx/>
-              <a:defRPr sz="2325">
-                <a:latin typeface="Times Roman"/>
-                <a:ea typeface="Times Roman"/>
-                <a:cs typeface="Times Roman"/>
-                <a:sym typeface="Times Roman"/>
-              </a:defRPr>
-            </a:pPr>
-            <a:r>
-              <a:t>Expand evaluation with more real-world queries</a:t>
+            <a:pPr lvl="1"/>
+            <a:r>
+              <a:rPr sz="1300" b="1"/>
+              <a:t>Extend to a multi-turn task-completion agent</a:t>
+            </a:r>
+            <a:r>
+              <a:rPr sz="1300" b="0"/>
+              <a:t> — add a planning layer + stateful execution on top of the existing supervisor / specialists / CRAG / fallback substrate (e.g., diagnose-then-guide-fix for industrial; multi-meal recipe planning with constraint tracking)</a:t>
+            </a:r>
+          </a:p>
+          <a:p>
+            <a:pPr lvl="1"/>
+            <a:r>
+              <a:rPr sz="1300" b="0"/>
+              <a:t>Add more domains and grow the synthesis / fallback coverage</a:t>
+            </a:r>
+          </a:p>
+          <a:p>
+            <a:pPr lvl="1"/>
+            <a:r>
+              <a:rPr sz="1300" b="0"/>
+              <a:t>Optimize latency — cache grader / hallucination-checker calls; explore the optional fine-tuned grader / router as a faster Tier-2</a:t>
+            </a:r>
+          </a:p>
+          <a:p>
+            <a:pPr lvl="1"/>
+            <a:r>
+              <a:rPr sz="1300" b="0"/>
+              <a:t>Better-calibrated routing confidence thresholds</a:t>
+            </a:r>
+          </a:p>
+          <a:p>
+            <a:pPr lvl="1"/>
+            <a:r>
+              <a:rPr sz="1300" b="0"/>
+              <a:t>Broader real-world evaluation beyond the curated 150-query set</a:t>
             </a:r>
           </a:p>
         </p:txBody>

</xml_diff>